<commit_message>
Add repo links to final slide
</commit_message>
<xml_diff>
--- a/reports/SmartToys_Business_Review.pptx
+++ b/reports/SmartToys_Business_Review.pptx
@@ -47429,16 +47429,7 @@
                 </a:solidFill>
                 <a:latin typeface="Be vietnam pro"/>
               </a:rPr>
-              <a:t>/</a:t>
-            </a:r>
-            <a:r>
-              <a:rPr lang="en-US" sz="1600">
-                <a:solidFill>
-                  <a:srgbClr val="384655"/>
-                </a:solidFill>
-                <a:latin typeface="Be vietnam pro"/>
-              </a:rPr>
-              <a:t>Analytics Engineer</a:t>
+              <a:t>/Analytics Engineer</a:t>
             </a:r>
             <a:endParaRPr lang="en-US" dirty="0">
               <a:latin typeface="Be vietnam pro"/>
@@ -47465,11 +47456,84 @@
             <a:r>
               <a:rPr sz="1400" b="1" dirty="0">
                 <a:solidFill>
-                  <a:srgbClr val="2E9CBF"/>
+                  <a:schemeClr val="tx1"/>
                 </a:solidFill>
                 <a:latin typeface="Be vietnam pro"/>
               </a:rPr>
-              <a:t>[link GitHub]</a:t>
+              <a:t>[</a:t>
+            </a:r>
+            <a:r>
+              <a:rPr sz="1400" b="1" dirty="0">
+                <a:solidFill>
+                  <a:srgbClr val="384655"/>
+                </a:solidFill>
+                <a:latin typeface="Be vietnam pro"/>
+                <a:hlinkClick r:id="rId3">
+                  <a:extLst>
+                    <a:ext uri="{A12FA001-AC4F-418D-AE19-62706E023703}">
+                      <ahyp:hlinkClr xmlns:ahyp="http://schemas.microsoft.com/office/drawing/2018/hyperlinkcolor" val="tx"/>
+                    </a:ext>
+                  </a:extLst>
+                </a:hlinkClick>
+              </a:rPr>
+              <a:t>link</a:t>
+            </a:r>
+            <a:r>
+              <a:rPr lang="en-US" sz="1400" b="1" dirty="0">
+                <a:solidFill>
+                  <a:srgbClr val="384655"/>
+                </a:solidFill>
+                <a:latin typeface="Be vietnam pro"/>
+                <a:hlinkClick r:id="rId3">
+                  <a:extLst>
+                    <a:ext uri="{A12FA001-AC4F-418D-AE19-62706E023703}">
+                      <ahyp:hlinkClr xmlns:ahyp="http://schemas.microsoft.com/office/drawing/2018/hyperlinkcolor" val="tx"/>
+                    </a:ext>
+                  </a:extLst>
+                </a:hlinkClick>
+              </a:rPr>
+              <a:t> </a:t>
+            </a:r>
+            <a:r>
+              <a:rPr lang="en-US" sz="1400" b="1" dirty="0" err="1">
+                <a:solidFill>
+                  <a:srgbClr val="384655"/>
+                </a:solidFill>
+                <a:latin typeface="Be vietnam pro"/>
+                <a:hlinkClick r:id="rId3">
+                  <a:extLst>
+                    <a:ext uri="{A12FA001-AC4F-418D-AE19-62706E023703}">
+                      <ahyp:hlinkClr xmlns:ahyp="http://schemas.microsoft.com/office/drawing/2018/hyperlinkcolor" val="tx"/>
+                    </a:ext>
+                  </a:extLst>
+                </a:hlinkClick>
+              </a:rPr>
+              <a:t>dẫn</a:t>
+            </a:r>
+            <a:r>
+              <a:rPr sz="1400" b="1" dirty="0">
+                <a:solidFill>
+                  <a:schemeClr val="tx1"/>
+                </a:solidFill>
+                <a:latin typeface="Be vietnam pro"/>
+                <a:hlinkClick r:id="rId3">
+                  <a:extLst>
+                    <a:ext uri="{A12FA001-AC4F-418D-AE19-62706E023703}">
+                      <ahyp:hlinkClr xmlns:ahyp="http://schemas.microsoft.com/office/drawing/2018/hyperlinkcolor" val="tx"/>
+                    </a:ext>
+                  </a:extLst>
+                </a:hlinkClick>
+              </a:rPr>
+              <a:t> GitHub</a:t>
+            </a:r>
+            <a:r>
+              <a:rPr sz="1400" b="1" dirty="0">
+                <a:solidFill>
+                  <a:schemeClr val="tx1"/>
+                </a:solidFill>
+                <a:latin typeface="Be vietnam pro"/>
+              </a:rPr>
+              <a:t>]</a:t>
             </a:r>
           </a:p>
           <a:p>
@@ -47529,11 +47593,36 @@
             <a:r>
               <a:rPr sz="1400" b="1" dirty="0">
                 <a:solidFill>
-                  <a:srgbClr val="2E9CBF"/>
+                  <a:schemeClr val="tx1"/>
                 </a:solidFill>
                 <a:latin typeface="Be vietnam pro"/>
               </a:rPr>
-              <a:t>[link notebook]</a:t>
+              <a:t>[</a:t>
+            </a:r>
+            <a:r>
+              <a:rPr sz="1400" b="1" dirty="0">
+                <a:solidFill>
+                  <a:schemeClr val="tx1"/>
+                </a:solidFill>
+                <a:latin typeface="Be vietnam pro"/>
+                <a:hlinkClick r:id="rId4">
+                  <a:extLst>
+                    <a:ext uri="{A12FA001-AC4F-418D-AE19-62706E023703}">
+                      <ahyp:hlinkClr xmlns:ahyp="http://schemas.microsoft.com/office/drawing/2018/hyperlinkcolor" val="tx"/>
+                    </a:ext>
+                  </a:extLst>
+                </a:hlinkClick>
+              </a:rPr>
+              <a:t>link notebook</a:t>
+            </a:r>
+            <a:r>
+              <a:rPr sz="1400" b="1" dirty="0">
+                <a:solidFill>
+                  <a:schemeClr val="tx1"/>
+                </a:solidFill>
+                <a:latin typeface="Be vietnam pro"/>
+              </a:rPr>
+              <a:t>]</a:t>
             </a:r>
           </a:p>
           <a:p>
@@ -47560,7 +47649,7 @@
                   <a:srgbClr val="2E9CBF"/>
                 </a:solidFill>
                 <a:latin typeface="Be vietnam pro"/>
-                <a:hlinkClick r:id="rId3"/>
+                <a:hlinkClick r:id="rId5"/>
               </a:rPr>
               <a:t>duyngoduyngo@gmail.com</a:t>
             </a:r>

</xml_diff>

<commit_message>
Add link to final slide
</commit_message>
<xml_diff>
--- a/reports/SmartToys_Business_Review.pptx
+++ b/reports/SmartToys_Business_Review.pptx
@@ -885,7 +885,7 @@
               </a:spcAft>
               <a:buNone/>
             </a:pPr>
-            <a:endParaRPr/>
+            <a:endParaRPr dirty="0"/>
           </a:p>
         </p:txBody>
       </p:sp>
@@ -52758,48 +52758,6 @@
           </a:p>
         </p:txBody>
       </p:sp>
-      <p:sp>
-        <p:nvSpPr>
-          <p:cNvPr id="984" name="TextBox 983"/>
-          <p:cNvSpPr txBox="1"/>
-          <p:nvPr/>
-        </p:nvSpPr>
-        <p:spPr>
-          <a:xfrm>
-            <a:off x="722376" y="4572000"/>
-            <a:ext cx="7708392" cy="233205"/>
-          </a:xfrm>
-          <a:prstGeom prst="rect">
-            <a:avLst/>
-          </a:prstGeom>
-          <a:noFill/>
-        </p:spPr>
-        <p:txBody>
-          <a:bodyPr wrap="square" lIns="0" tIns="0" rIns="0" bIns="0" anchor="t">
-            <a:spAutoFit/>
-          </a:bodyPr>
-          <a:lstStyle/>
-          <a:p>
-            <a:pPr algn="l">
-              <a:lnSpc>
-                <a:spcPct val="115000"/>
-              </a:lnSpc>
-              <a:spcAft>
-                <a:spcPts val="0"/>
-              </a:spcAft>
-            </a:pPr>
-            <a:r>
-              <a:rPr sz="1400" b="0">
-                <a:solidFill>
-                  <a:srgbClr val="C9D3DD"/>
-                </a:solidFill>
-                <a:latin typeface="Be vietnam pro"/>
-              </a:rPr>
-              <a:t>Deck này trình bày các phát hiện chính. Toàn bộ 20 biểu đồ và mã nguồn có trong notebook đầy đủ.</a:t>
-            </a:r>
-          </a:p>
-        </p:txBody>
-      </p:sp>
     </p:spTree>
   </p:cSld>
   <p:clrMapOvr>

</xml_diff>